<commit_message>
Update ReID project documentation
</commit_message>
<xml_diff>
--- a/presentation_deck_v4.pptx
+++ b/presentation_deck_v4.pptx
@@ -2108,8 +2108,8 @@
         </p:blipFill>
         <p:spPr>
           <a:xfrm>
-            <a:off x="970280" y="822960"/>
-            <a:ext cx="7203439" cy="3813807"/>
+            <a:off x="645980" y="822960"/>
+            <a:ext cx="7735234" cy="4095362"/>
           </a:xfrm>
           <a:prstGeom prst="rect">
             <a:avLst/>
@@ -4180,8 +4180,8 @@
         </p:nvSpPr>
         <p:spPr>
           <a:xfrm flipH="1">
-            <a:off x="5303520" y="1984248"/>
-            <a:ext cx="2468880" cy="978408"/>
+            <a:off x="4754880" y="1984248"/>
+            <a:ext cx="3017519" cy="978408"/>
           </a:xfrm>
           <a:prstGeom prst="line">
             <a:avLst/>
@@ -5351,7 +5351,7 @@
                 <a:ea typeface="Calibri" pitchFamily="34" charset="-122"/>
                 <a:cs typeface="Calibri" pitchFamily="34" charset="-120"/>
               </a:rPr>
-              <a:t>Where This Fits</a:t>
+              <a:t>Tech Stack</a:t>
             </a:r>
             <a:endParaRPr lang="en-US" sz="3200" dirty="0"/>
           </a:p>
@@ -5366,7 +5366,7 @@
           <p:nvPr>
             <p:extLst>
               <p:ext uri="{D42A27DB-BD31-4B8C-83A1-F6EECF244321}">
-                <p14:modId xmlns:p14="http://schemas.microsoft.com/office/powerpoint/2010/main" val="405173607"/>
+                <p14:modId xmlns:p14="http://schemas.microsoft.com/office/powerpoint/2010/main" val="1555005957"/>
               </p:ext>
             </p:extLst>
           </p:nvPr>
@@ -5691,6 +5691,17 @@
                         <a:buNone/>
                       </a:pPr>
                       <a:r>
+                        <a:rPr lang="en-US" sz="1400" b="1" dirty="0" err="1">
+                          <a:solidFill>
+                            <a:srgbClr val="D4D4D4"/>
+                          </a:solidFill>
+                          <a:latin typeface="Calibri" pitchFamily="34" charset="0"/>
+                          <a:ea typeface="Calibri" pitchFamily="34" charset="-122"/>
+                          <a:cs typeface="Calibri" pitchFamily="34" charset="-120"/>
+                        </a:rPr>
+                        <a:t>Openrouter</a:t>
+                      </a:r>
+                      <a:r>
                         <a:rPr lang="en-US" sz="1400" b="1" dirty="0">
                           <a:solidFill>
                             <a:srgbClr val="D4D4D4"/>
@@ -5699,7 +5710,7 @@
                           <a:ea typeface="Calibri" pitchFamily="34" charset="-122"/>
                           <a:cs typeface="Calibri" pitchFamily="34" charset="-120"/>
                         </a:rPr>
-                        <a:t>CrewAI / AutoGen</a:t>
+                        <a:t> / OpenAI</a:t>
                       </a:r>
                       <a:endParaRPr lang="en-US" sz="1400" dirty="0">
                         <a:latin typeface="Calibri" charset="0"/>
@@ -5767,7 +5778,7 @@
                           <a:ea typeface="Calibri" pitchFamily="34" charset="-122"/>
                           <a:cs typeface="Calibri" pitchFamily="34" charset="-120"/>
                         </a:rPr>
-                        <a:t>Agent-centric orchestration, a different model entirely.</a:t>
+                        <a:t>AI Agent model provider, multiple different models to choose from.</a:t>
                       </a:r>
                       <a:endParaRPr lang="en-US" sz="1400" dirty="0">
                         <a:solidFill>
@@ -5845,7 +5856,7 @@
                           <a:ea typeface="Calibri" pitchFamily="34" charset="-122"/>
                           <a:cs typeface="Calibri" pitchFamily="34" charset="-120"/>
                         </a:rPr>
-                        <a:t>This pattern</a:t>
+                        <a:t>Surrounding python code</a:t>
                       </a:r>
                       <a:endParaRPr lang="en-US" sz="1400" dirty="0">
                         <a:latin typeface="Calibri" charset="0"/>
@@ -6043,7 +6054,7 @@
                 <a:ea typeface="Calibri" pitchFamily="34" charset="-122"/>
                 <a:cs typeface="Calibri" pitchFamily="34" charset="-120"/>
               </a:rPr>
-              <a:t>pipelines needing, understandability, auditability, iterative LLM-driven improvement</a:t>
+              <a:t>pipelines needing understandability, auditability, iterative LLM-driven improvement</a:t>
             </a:r>
             <a:endParaRPr lang="en-US" sz="1200" dirty="0"/>
           </a:p>
@@ -9717,7 +9728,7 @@
         </p:nvSpPr>
         <p:spPr>
           <a:xfrm>
-            <a:off x="2940829" y="695681"/>
+            <a:off x="2592768" y="822960"/>
             <a:ext cx="2560320" cy="301752"/>
           </a:xfrm>
           <a:prstGeom prst="rect">
@@ -9742,7 +9753,7 @@
         </p:nvSpPr>
         <p:spPr>
           <a:xfrm>
-            <a:off x="2940829" y="695681"/>
+            <a:off x="2592768" y="836823"/>
             <a:ext cx="2560320" cy="301752"/>
           </a:xfrm>
           <a:prstGeom prst="rect">
@@ -9781,7 +9792,7 @@
         </p:nvSpPr>
         <p:spPr>
           <a:xfrm>
-            <a:off x="2126126" y="4608576"/>
+            <a:off x="2126126" y="4741017"/>
             <a:ext cx="2962656" cy="301752"/>
           </a:xfrm>
           <a:prstGeom prst="rect">
@@ -9806,7 +9817,7 @@
         </p:nvSpPr>
         <p:spPr>
           <a:xfrm>
-            <a:off x="2126126" y="4608576"/>
+            <a:off x="2126126" y="4754880"/>
             <a:ext cx="2962656" cy="301752"/>
           </a:xfrm>
           <a:prstGeom prst="rect">
@@ -9845,7 +9856,7 @@
         </p:nvSpPr>
         <p:spPr>
           <a:xfrm>
-            <a:off x="5501149" y="4529918"/>
+            <a:off x="5501149" y="4741017"/>
             <a:ext cx="2542032" cy="301752"/>
           </a:xfrm>
           <a:prstGeom prst="rect">
@@ -9870,7 +9881,7 @@
         </p:nvSpPr>
         <p:spPr>
           <a:xfrm>
-            <a:off x="5501149" y="4529918"/>
+            <a:off x="5501149" y="4741017"/>
             <a:ext cx="2542032" cy="301752"/>
           </a:xfrm>
           <a:prstGeom prst="rect">
@@ -9962,7 +9973,7 @@
         </p:blipFill>
         <p:spPr>
           <a:xfrm>
-            <a:off x="1442392" y="1041482"/>
+            <a:off x="1442392" y="1215538"/>
             <a:ext cx="6442095" cy="3420790"/>
           </a:xfrm>
           <a:prstGeom prst="rect">

</xml_diff>